<commit_message>
Legg til økosystemvisualisering og oppdaterte presentasjoner
- Ny interaktiv økosystemvisualisering (okosystem-verdikjede.html)
  med målet i sentrum, ikke verdikjeden. Fire konsentriske ringer:
  beslutningstakere, offentlig verdikjede, andre kunnskapsleverandører,
  rammesettere og infrastruktur.
- Ny presentasjon KI-klareData.pptx
- Oppdaterer visualiseringer/index.md med oppslag om økosystem-vis.
- Oppdaterte versjoner av HdirMal.pptx, verdikjede.pptx og
  visualiseringer/utfordringsbildet-forankring.pptx (sistnevnte er
  duplikat av Presentasjoner/utfordringsbildet-forankring.pptx
  som ligger utenfor repoet)

Co-Authored-By: Claude Opus 4.7 (1M context) <noreply@anthropic.com>
</commit_message>
<xml_diff>
--- a/HdirMal.pptx
+++ b/HdirMal.pptx
@@ -11444,10 +11444,10 @@
 <file path=customXml/item1.xml><?xml version="1.0" encoding="utf-8"?>
 <p:properties xmlns:p="http://schemas.microsoft.com/office/2006/metadata/properties" xmlns:xsi="http://www.w3.org/2001/XMLSchema-instance" xmlns:pc="http://schemas.microsoft.com/office/infopath/2007/PartnerControls">
   <documentManagement>
-    <lcf76f155ced4ddcb4097134ff3c332f xmlns="8d83cb3e-5469-4ba3-8e7f-a0f40b26c827">
+    <lcf76f155ced4ddcb4097134ff3c332f xmlns="1063c122-4bbe-4826-b48d-9d0fb0a65790">
       <Terms xmlns="http://schemas.microsoft.com/office/infopath/2007/PartnerControls"/>
     </lcf76f155ced4ddcb4097134ff3c332f>
-    <TaxCatchAll xmlns="c56c3c49-4b7b-4732-b272-724ee8eca3e9" xsi:nil="true"/>
+    <TaxCatchAll xmlns="6f2d6c3d-a81e-4dca-8790-2d5b1d74c7c5" xsi:nil="true"/>
   </documentManagement>
 </p:properties>
 </file>
@@ -11462,10 +11462,10 @@
 </file>
 
 <file path=customXml/item3.xml><?xml version="1.0" encoding="utf-8"?>
-<ct:contentTypeSchema xmlns:ct="http://schemas.microsoft.com/office/2006/metadata/contentType" xmlns:ma="http://schemas.microsoft.com/office/2006/metadata/properties/metaAttributes" ct:_="" ma:_="" ma:contentTypeName="Dokument" ma:contentTypeID="0x010100A4D641ED0601B84E95C7730E98590A11" ma:contentTypeVersion="10" ma:contentTypeDescription="Opprett et nytt dokument." ma:contentTypeScope="" ma:versionID="d4446fe98beed284ee3c4cdeaf23c6e6">
-  <xsd:schema xmlns:xsd="http://www.w3.org/2001/XMLSchema" xmlns:xs="http://www.w3.org/2001/XMLSchema" xmlns:p="http://schemas.microsoft.com/office/2006/metadata/properties" xmlns:ns2="8d83cb3e-5469-4ba3-8e7f-a0f40b26c827" xmlns:ns3="c56c3c49-4b7b-4732-b272-724ee8eca3e9" targetNamespace="http://schemas.microsoft.com/office/2006/metadata/properties" ma:root="true" ma:fieldsID="e8390578ca246f8405023ccaa1c91ee3" ns2:_="" ns3:_="">
-    <xsd:import namespace="8d83cb3e-5469-4ba3-8e7f-a0f40b26c827"/>
-    <xsd:import namespace="c56c3c49-4b7b-4732-b272-724ee8eca3e9"/>
+<ct:contentTypeSchema xmlns:ct="http://schemas.microsoft.com/office/2006/metadata/contentType" xmlns:ma="http://schemas.microsoft.com/office/2006/metadata/properties/metaAttributes" ct:_="" ma:_="" ma:contentTypeName="Document" ma:contentTypeID="0x010100751D05E13A0CAE4FAEB0483BDB291AAE" ma:contentTypeVersion="10" ma:contentTypeDescription="Create a new document." ma:contentTypeScope="" ma:versionID="79aea1d05ac3e5b98de28b9e06920632">
+  <xsd:schema xmlns:xsd="http://www.w3.org/2001/XMLSchema" xmlns:xs="http://www.w3.org/2001/XMLSchema" xmlns:p="http://schemas.microsoft.com/office/2006/metadata/properties" xmlns:ns2="1063c122-4bbe-4826-b48d-9d0fb0a65790" xmlns:ns3="6f2d6c3d-a81e-4dca-8790-2d5b1d74c7c5" targetNamespace="http://schemas.microsoft.com/office/2006/metadata/properties" ma:root="true" ma:fieldsID="41760dbbac4dbb66fef1edba5d3279e3" ns2:_="" ns3:_="">
+    <xsd:import namespace="1063c122-4bbe-4826-b48d-9d0fb0a65790"/>
+    <xsd:import namespace="6f2d6c3d-a81e-4dca-8790-2d5b1d74c7c5"/>
     <xsd:element name="properties">
       <xsd:complexType>
         <xsd:sequence>
@@ -11474,13 +11474,13 @@
               <xsd:all>
                 <xsd:element ref="ns2:MediaServiceMetadata" minOccurs="0"/>
                 <xsd:element ref="ns2:MediaServiceFastMetadata" minOccurs="0"/>
+                <xsd:element ref="ns2:MediaServiceSearchProperties" minOccurs="0"/>
+                <xsd:element ref="ns2:MediaServiceDateTaken" minOccurs="0"/>
                 <xsd:element ref="ns2:lcf76f155ced4ddcb4097134ff3c332f" minOccurs="0"/>
                 <xsd:element ref="ns3:TaxCatchAll" minOccurs="0"/>
-                <xsd:element ref="ns2:MediaServiceObjectDetectorVersions" minOccurs="0"/>
                 <xsd:element ref="ns2:MediaServiceOCR" minOccurs="0"/>
                 <xsd:element ref="ns2:MediaServiceGenerationTime" minOccurs="0"/>
                 <xsd:element ref="ns2:MediaServiceEventHashCode" minOccurs="0"/>
-                <xsd:element ref="ns2:MediaServiceSearchProperties" minOccurs="0"/>
               </xsd:all>
             </xsd:complexType>
           </xsd:element>
@@ -11488,7 +11488,7 @@
       </xsd:complexType>
     </xsd:element>
   </xsd:schema>
-  <xsd:schema xmlns:xsd="http://www.w3.org/2001/XMLSchema" xmlns:xs="http://www.w3.org/2001/XMLSchema" xmlns:dms="http://schemas.microsoft.com/office/2006/documentManagement/types" xmlns:pc="http://schemas.microsoft.com/office/infopath/2007/PartnerControls" targetNamespace="8d83cb3e-5469-4ba3-8e7f-a0f40b26c827" elementFormDefault="qualified">
+  <xsd:schema xmlns:xsd="http://www.w3.org/2001/XMLSchema" xmlns:xs="http://www.w3.org/2001/XMLSchema" xmlns:dms="http://schemas.microsoft.com/office/2006/documentManagement/types" xmlns:pc="http://schemas.microsoft.com/office/infopath/2007/PartnerControls" targetNamespace="1063c122-4bbe-4826-b48d-9d0fb0a65790" elementFormDefault="qualified">
     <xsd:import namespace="http://schemas.microsoft.com/office/2006/documentManagement/types"/>
     <xsd:import namespace="http://schemas.microsoft.com/office/infopath/2007/PartnerControls"/>
     <xsd:element name="MediaServiceMetadata" ma:index="8" nillable="true" ma:displayName="MediaServiceMetadata" ma:hidden="true" ma:internalName="MediaServiceMetadata" ma:readOnly="true">
@@ -11501,45 +11501,45 @@
         <xsd:restriction base="dms:Note"/>
       </xsd:simpleType>
     </xsd:element>
-    <xsd:element name="lcf76f155ced4ddcb4097134ff3c332f" ma:index="11" nillable="true" ma:taxonomy="true" ma:internalName="lcf76f155ced4ddcb4097134ff3c332f" ma:taxonomyFieldName="MediaServiceImageTags" ma:displayName="Bildemerkelapper" ma:readOnly="false" ma:fieldId="{5cf76f15-5ced-4ddc-b409-7134ff3c332f}" ma:taxonomyMulti="true" ma:sspId="44bd27e2-62de-4af1-85f7-19d8bf2bfc53" ma:termSetId="09814cd3-568e-fe90-9814-8d621ff8fb84" ma:anchorId="fba54fb3-c3e1-fe81-a776-ca4b69148c4d" ma:open="true" ma:isKeyword="false">
+    <xsd:element name="MediaServiceSearchProperties" ma:index="10" nillable="true" ma:displayName="MediaServiceSearchProperties" ma:hidden="true" ma:internalName="MediaServiceSearchProperties" ma:readOnly="true">
+      <xsd:simpleType>
+        <xsd:restriction base="dms:Note"/>
+      </xsd:simpleType>
+    </xsd:element>
+    <xsd:element name="MediaServiceDateTaken" ma:index="11" nillable="true" ma:displayName="MediaServiceDateTaken" ma:hidden="true" ma:indexed="true" ma:internalName="MediaServiceDateTaken" ma:readOnly="true">
+      <xsd:simpleType>
+        <xsd:restriction base="dms:Text"/>
+      </xsd:simpleType>
+    </xsd:element>
+    <xsd:element name="lcf76f155ced4ddcb4097134ff3c332f" ma:index="13" nillable="true" ma:taxonomy="true" ma:internalName="lcf76f155ced4ddcb4097134ff3c332f" ma:taxonomyFieldName="MediaServiceImageTags" ma:displayName="Image Tags" ma:readOnly="false" ma:fieldId="{5cf76f15-5ced-4ddc-b409-7134ff3c332f}" ma:taxonomyMulti="true" ma:sspId="44bd27e2-62de-4af1-85f7-19d8bf2bfc53" ma:termSetId="09814cd3-568e-fe90-9814-8d621ff8fb84" ma:anchorId="fba54fb3-c3e1-fe81-a776-ca4b69148c4d" ma:open="true" ma:isKeyword="false">
       <xsd:complexType>
         <xsd:sequence>
           <xsd:element ref="pc:Terms" minOccurs="0" maxOccurs="1"/>
         </xsd:sequence>
       </xsd:complexType>
     </xsd:element>
-    <xsd:element name="MediaServiceObjectDetectorVersions" ma:index="13" nillable="true" ma:displayName="MediaServiceObjectDetectorVersions" ma:hidden="true" ma:indexed="true" ma:internalName="MediaServiceObjectDetectorVersions" ma:readOnly="true">
-      <xsd:simpleType>
-        <xsd:restriction base="dms:Text"/>
-      </xsd:simpleType>
-    </xsd:element>
-    <xsd:element name="MediaServiceOCR" ma:index="14" nillable="true" ma:displayName="Extracted Text" ma:internalName="MediaServiceOCR" ma:readOnly="true">
+    <xsd:element name="MediaServiceOCR" ma:index="15" nillable="true" ma:displayName="Extracted Text" ma:internalName="MediaServiceOCR" ma:readOnly="true">
       <xsd:simpleType>
         <xsd:restriction base="dms:Note">
           <xsd:maxLength value="255"/>
         </xsd:restriction>
       </xsd:simpleType>
     </xsd:element>
-    <xsd:element name="MediaServiceGenerationTime" ma:index="15" nillable="true" ma:displayName="MediaServiceGenerationTime" ma:hidden="true" ma:internalName="MediaServiceGenerationTime" ma:readOnly="true">
+    <xsd:element name="MediaServiceGenerationTime" ma:index="16" nillable="true" ma:displayName="MediaServiceGenerationTime" ma:hidden="true" ma:internalName="MediaServiceGenerationTime" ma:readOnly="true">
       <xsd:simpleType>
         <xsd:restriction base="dms:Text"/>
       </xsd:simpleType>
     </xsd:element>
-    <xsd:element name="MediaServiceEventHashCode" ma:index="16" nillable="true" ma:displayName="MediaServiceEventHashCode" ma:hidden="true" ma:internalName="MediaServiceEventHashCode" ma:readOnly="true">
+    <xsd:element name="MediaServiceEventHashCode" ma:index="17" nillable="true" ma:displayName="MediaServiceEventHashCode" ma:hidden="true" ma:internalName="MediaServiceEventHashCode" ma:readOnly="true">
       <xsd:simpleType>
         <xsd:restriction base="dms:Text"/>
       </xsd:simpleType>
     </xsd:element>
-    <xsd:element name="MediaServiceSearchProperties" ma:index="17" nillable="true" ma:displayName="MediaServiceSearchProperties" ma:hidden="true" ma:internalName="MediaServiceSearchProperties" ma:readOnly="true">
-      <xsd:simpleType>
-        <xsd:restriction base="dms:Note"/>
-      </xsd:simpleType>
-    </xsd:element>
   </xsd:schema>
-  <xsd:schema xmlns:xsd="http://www.w3.org/2001/XMLSchema" xmlns:xs="http://www.w3.org/2001/XMLSchema" xmlns:dms="http://schemas.microsoft.com/office/2006/documentManagement/types" xmlns:pc="http://schemas.microsoft.com/office/infopath/2007/PartnerControls" targetNamespace="c56c3c49-4b7b-4732-b272-724ee8eca3e9" elementFormDefault="qualified">
+  <xsd:schema xmlns:xsd="http://www.w3.org/2001/XMLSchema" xmlns:xs="http://www.w3.org/2001/XMLSchema" xmlns:dms="http://schemas.microsoft.com/office/2006/documentManagement/types" xmlns:pc="http://schemas.microsoft.com/office/infopath/2007/PartnerControls" targetNamespace="6f2d6c3d-a81e-4dca-8790-2d5b1d74c7c5" elementFormDefault="qualified">
     <xsd:import namespace="http://schemas.microsoft.com/office/2006/documentManagement/types"/>
     <xsd:import namespace="http://schemas.microsoft.com/office/infopath/2007/PartnerControls"/>
-    <xsd:element name="TaxCatchAll" ma:index="12" nillable="true" ma:displayName="Taxonomy Catch All Column" ma:hidden="true" ma:list="{4812a2d0-645d-4f23-9e48-ace78da76045}" ma:internalName="TaxCatchAll" ma:showField="CatchAllData" ma:web="c56c3c49-4b7b-4732-b272-724ee8eca3e9">
+    <xsd:element name="TaxCatchAll" ma:index="14" nillable="true" ma:displayName="Taxonomy Catch All Column" ma:hidden="true" ma:list="{9604ea7e-7ecf-4376-a85b-280f98472f3a}" ma:internalName="TaxCatchAll" ma:showField="CatchAllData" ma:web="6f2d6c3d-a81e-4dca-8790-2d5b1d74c7c5">
       <xsd:complexType>
         <xsd:complexContent>
           <xsd:extension base="dms:MultiChoiceLookup">
@@ -11560,8 +11560,8 @@
         <xsd:element ref="dc:creator" minOccurs="0" maxOccurs="1"/>
         <xsd:element ref="dcterms:created" minOccurs="0" maxOccurs="1"/>
         <xsd:element ref="dc:identifier" minOccurs="0" maxOccurs="1"/>
-        <xsd:element name="contentType" minOccurs="0" maxOccurs="1" type="xsd:string" ma:index="0" ma:displayName="Innholdstype"/>
-        <xsd:element ref="dc:title" minOccurs="0" maxOccurs="1" ma:index="4" ma:displayName="Tittel"/>
+        <xsd:element name="contentType" minOccurs="0" maxOccurs="1" type="xsd:string" ma:index="0" ma:displayName="Content Type"/>
+        <xsd:element ref="dc:title" minOccurs="0" maxOccurs="1" ma:index="4" ma:displayName="Title"/>
         <xsd:element ref="dc:subject" minOccurs="0" maxOccurs="1"/>
         <xsd:element ref="dc:description" minOccurs="0" maxOccurs="1"/>
         <xsd:element name="keywords" minOccurs="0" maxOccurs="1" type="xsd:string"/>
@@ -11670,20 +11670,5 @@
 </file>
 
 <file path=customXml/itemProps3.xml><?xml version="1.0" encoding="utf-8"?>
-<ds:datastoreItem xmlns:ds="http://schemas.openxmlformats.org/officeDocument/2006/customXml" ds:itemID="{D406CC38-64B4-4842-9ED1-8E27A76D0759}">
-  <ds:schemaRefs>
-    <ds:schemaRef ds:uri="http://schemas.microsoft.com/office/2006/metadata/contentType"/>
-    <ds:schemaRef ds:uri="http://schemas.microsoft.com/office/2006/metadata/properties/metaAttributes"/>
-    <ds:schemaRef ds:uri="http://www.w3.org/2001/XMLSchema"/>
-    <ds:schemaRef ds:uri="http://schemas.microsoft.com/office/2006/metadata/properties"/>
-    <ds:schemaRef ds:uri="8d83cb3e-5469-4ba3-8e7f-a0f40b26c827"/>
-    <ds:schemaRef ds:uri="c56c3c49-4b7b-4732-b272-724ee8eca3e9"/>
-    <ds:schemaRef ds:uri="http://schemas.microsoft.com/office/2006/documentManagement/types"/>
-    <ds:schemaRef ds:uri="http://schemas.microsoft.com/office/infopath/2007/PartnerControls"/>
-    <ds:schemaRef ds:uri="http://schemas.openxmlformats.org/package/2006/metadata/core-properties"/>
-    <ds:schemaRef ds:uri="http://purl.org/dc/elements/1.1/"/>
-    <ds:schemaRef ds:uri="http://purl.org/dc/terms/"/>
-    <ds:schemaRef ds:uri="http://schemas.microsoft.com/internal/obd"/>
-  </ds:schemaRefs>
-</ds:datastoreItem>
+<ds:datastoreItem xmlns:ds="http://schemas.openxmlformats.org/officeDocument/2006/customXml" ds:itemID="{B49D9611-2DBE-4E35-AB52-031C4A3BD95C}"/>
 </file>
</xml_diff>